<commit_message>
Cross-check visual: altura de cartao adaptavel, logo oficial Starbem embutida, PDF de conferencia
</commit_message>
<xml_diff>
--- a/docs/conversa-ceo/apresentacao.pptx
+++ b/docs/conversa-ceo/apresentacao.pptx
@@ -3165,49 +3165,30 @@
           </a:p>
         </p:txBody>
       </p:sp>
-      <p:sp>
-        <p:nvSpPr>
-          <p:cNvPr id="3" name="TextBox 2"/>
-          <p:cNvSpPr txBox="1"/>
-          <p:nvPr/>
-        </p:nvSpPr>
-        <p:spPr>
-          <a:xfrm>
-            <a:off x="640080" y="548640"/>
-            <a:ext cx="4114800" cy="548640"/>
-          </a:xfrm>
-          <a:prstGeom prst="rect">
-            <a:avLst/>
-          </a:prstGeom>
-          <a:noFill/>
-        </p:spPr>
-        <p:txBody>
-          <a:bodyPr wrap="square" anchor="ctr">
-            <a:spAutoFit/>
-          </a:bodyPr>
-          <a:lstStyle/>
-          <a:p>
-            <a:r>
-              <a:rPr sz="2600" b="1">
-                <a:solidFill>
-                  <a:srgbClr val="FFFFFF"/>
-                </a:solidFill>
-                <a:latin typeface="Calibri"/>
-              </a:rPr>
-              <a:t>★ </a:t>
-            </a:r>
-            <a:r>
-              <a:rPr sz="2400" b="1">
-                <a:solidFill>
-                  <a:srgbClr val="FFFFFF"/>
-                </a:solidFill>
-                <a:latin typeface="Funnel Display"/>
-              </a:rPr>
-              <a:t>starbem</a:t>
-            </a:r>
-          </a:p>
-        </p:txBody>
-      </p:sp>
+      <p:pic>
+        <p:nvPicPr>
+          <p:cNvPr id="3" name="Picture 2" descr="starbem-logo-white.png"/>
+          <p:cNvPicPr>
+            <a:picLocks noChangeAspect="1"/>
+          </p:cNvPicPr>
+          <p:nvPr/>
+        </p:nvPicPr>
+        <p:blipFill>
+          <a:blip r:embed="rId2"/>
+          <a:stretch>
+            <a:fillRect/>
+          </a:stretch>
+        </p:blipFill>
+        <p:spPr>
+          <a:xfrm>
+            <a:off x="658368" y="548640"/>
+            <a:ext cx="2139351" cy="566928"/>
+          </a:xfrm>
+          <a:prstGeom prst="rect">
+            <a:avLst/>
+          </a:prstGeom>
+        </p:spPr>
+      </p:pic>
       <p:sp>
         <p:nvSpPr>
           <p:cNvPr id="4" name="TextBox 3"/>
@@ -3394,16 +3375,40 @@
           </a:p>
         </p:txBody>
       </p:sp>
-      <p:sp>
-        <p:nvSpPr>
-          <p:cNvPr id="3" name="TextBox 2"/>
+      <p:pic>
+        <p:nvPicPr>
+          <p:cNvPr id="3" name="Picture 2" descr="starbem-logo-white.png"/>
+          <p:cNvPicPr>
+            <a:picLocks noChangeAspect="1"/>
+          </p:cNvPicPr>
+          <p:nvPr/>
+        </p:nvPicPr>
+        <p:blipFill>
+          <a:blip r:embed="rId2"/>
+          <a:stretch>
+            <a:fillRect/>
+          </a:stretch>
+        </p:blipFill>
+        <p:spPr>
+          <a:xfrm>
+            <a:off x="548640" y="265176"/>
+            <a:ext cx="1449238" cy="384048"/>
+          </a:xfrm>
+          <a:prstGeom prst="rect">
+            <a:avLst/>
+          </a:prstGeom>
+        </p:spPr>
+      </p:pic>
+      <p:sp>
+        <p:nvSpPr>
+          <p:cNvPr id="4" name="TextBox 3"/>
           <p:cNvSpPr txBox="1"/>
           <p:nvPr/>
         </p:nvSpPr>
         <p:spPr>
           <a:xfrm>
-            <a:off x="502920" y="182880"/>
-            <a:ext cx="4114800" cy="548640"/>
+            <a:off x="5486400" y="182880"/>
+            <a:ext cx="6217920" cy="548640"/>
           </a:xfrm>
           <a:prstGeom prst="rect">
             <a:avLst/>
@@ -3416,49 +3421,6 @@
           </a:bodyPr>
           <a:lstStyle/>
           <a:p>
-            <a:r>
-              <a:rPr sz="2200" b="1">
-                <a:solidFill>
-                  <a:srgbClr val="FFFFFF"/>
-                </a:solidFill>
-                <a:latin typeface="Calibri"/>
-              </a:rPr>
-              <a:t>★ </a:t>
-            </a:r>
-            <a:r>
-              <a:rPr sz="2000" b="1">
-                <a:solidFill>
-                  <a:srgbClr val="FFFFFF"/>
-                </a:solidFill>
-                <a:latin typeface="Funnel Display"/>
-              </a:rPr>
-              <a:t>starbem</a:t>
-            </a:r>
-          </a:p>
-        </p:txBody>
-      </p:sp>
-      <p:sp>
-        <p:nvSpPr>
-          <p:cNvPr id="4" name="TextBox 3"/>
-          <p:cNvSpPr txBox="1"/>
-          <p:nvPr/>
-        </p:nvSpPr>
-        <p:spPr>
-          <a:xfrm>
-            <a:off x="5486400" y="182880"/>
-            <a:ext cx="6217920" cy="548640"/>
-          </a:xfrm>
-          <a:prstGeom prst="rect">
-            <a:avLst/>
-          </a:prstGeom>
-          <a:noFill/>
-        </p:spPr>
-        <p:txBody>
-          <a:bodyPr wrap="square" anchor="ctr">
-            <a:spAutoFit/>
-          </a:bodyPr>
-          <a:lstStyle/>
-          <a:p>
             <a:pPr algn="ctr"/>
             <a:r>
               <a:rPr sz="1500" b="1">
@@ -3514,7 +3476,7 @@
         </p:nvSpPr>
         <p:spPr>
           <a:xfrm>
-            <a:off x="548640" y="2423160"/>
+            <a:off x="548640" y="2945892"/>
             <a:ext cx="5303520" cy="457200"/>
           </a:xfrm>
           <a:prstGeom prst="roundRect">
@@ -3560,7 +3522,7 @@
         </p:nvSpPr>
         <p:spPr>
           <a:xfrm>
-            <a:off x="777240" y="2423160"/>
+            <a:off x="777240" y="2945892"/>
             <a:ext cx="4846320" cy="457200"/>
           </a:xfrm>
           <a:prstGeom prst="rect">
@@ -3594,8 +3556,8 @@
         </p:nvSpPr>
         <p:spPr>
           <a:xfrm>
-            <a:off x="548640" y="2926080"/>
-            <a:ext cx="5303520" cy="3154680"/>
+            <a:off x="548640" y="3448812"/>
+            <a:ext cx="5303520" cy="2337816"/>
           </a:xfrm>
           <a:prstGeom prst="roundRect">
             <a:avLst>
@@ -3642,8 +3604,8 @@
         </p:nvSpPr>
         <p:spPr>
           <a:xfrm>
-            <a:off x="868680" y="3154680"/>
-            <a:ext cx="4663440" cy="2697480"/>
+            <a:off x="868680" y="3686555"/>
+            <a:ext cx="4663440" cy="1926335"/>
           </a:xfrm>
           <a:prstGeom prst="rect">
             <a:avLst/>
@@ -3795,7 +3757,7 @@
         </p:nvSpPr>
         <p:spPr>
           <a:xfrm>
-            <a:off x="6336792" y="2423160"/>
+            <a:off x="6336792" y="2945892"/>
             <a:ext cx="5303520" cy="457200"/>
           </a:xfrm>
           <a:prstGeom prst="roundRect">
@@ -3841,7 +3803,7 @@
         </p:nvSpPr>
         <p:spPr>
           <a:xfrm>
-            <a:off x="6565392" y="2423160"/>
+            <a:off x="6565392" y="2945892"/>
             <a:ext cx="4846320" cy="457200"/>
           </a:xfrm>
           <a:prstGeom prst="rect">
@@ -3875,8 +3837,8 @@
         </p:nvSpPr>
         <p:spPr>
           <a:xfrm>
-            <a:off x="6336792" y="2926080"/>
-            <a:ext cx="5303520" cy="3154680"/>
+            <a:off x="6336792" y="3448812"/>
+            <a:ext cx="5303520" cy="2337816"/>
           </a:xfrm>
           <a:prstGeom prst="roundRect">
             <a:avLst>
@@ -3923,8 +3885,8 @@
         </p:nvSpPr>
         <p:spPr>
           <a:xfrm>
-            <a:off x="6656831" y="3154680"/>
-            <a:ext cx="4663440" cy="2697480"/>
+            <a:off x="6656831" y="3686555"/>
+            <a:ext cx="4663440" cy="1926335"/>
           </a:xfrm>
           <a:prstGeom prst="rect">
             <a:avLst/>
@@ -4181,16 +4143,40 @@
           </a:p>
         </p:txBody>
       </p:sp>
-      <p:sp>
-        <p:nvSpPr>
-          <p:cNvPr id="3" name="TextBox 2"/>
+      <p:pic>
+        <p:nvPicPr>
+          <p:cNvPr id="3" name="Picture 2" descr="starbem-logo-white.png"/>
+          <p:cNvPicPr>
+            <a:picLocks noChangeAspect="1"/>
+          </p:cNvPicPr>
+          <p:nvPr/>
+        </p:nvPicPr>
+        <p:blipFill>
+          <a:blip r:embed="rId2"/>
+          <a:stretch>
+            <a:fillRect/>
+          </a:stretch>
+        </p:blipFill>
+        <p:spPr>
+          <a:xfrm>
+            <a:off x="548640" y="265176"/>
+            <a:ext cx="1449238" cy="384048"/>
+          </a:xfrm>
+          <a:prstGeom prst="rect">
+            <a:avLst/>
+          </a:prstGeom>
+        </p:spPr>
+      </p:pic>
+      <p:sp>
+        <p:nvSpPr>
+          <p:cNvPr id="4" name="TextBox 3"/>
           <p:cNvSpPr txBox="1"/>
           <p:nvPr/>
         </p:nvSpPr>
         <p:spPr>
           <a:xfrm>
-            <a:off x="502920" y="182880"/>
-            <a:ext cx="4114800" cy="548640"/>
+            <a:off x="5486400" y="182880"/>
+            <a:ext cx="6217920" cy="548640"/>
           </a:xfrm>
           <a:prstGeom prst="rect">
             <a:avLst/>
@@ -4203,49 +4189,6 @@
           </a:bodyPr>
           <a:lstStyle/>
           <a:p>
-            <a:r>
-              <a:rPr sz="2200" b="1">
-                <a:solidFill>
-                  <a:srgbClr val="FFFFFF"/>
-                </a:solidFill>
-                <a:latin typeface="Calibri"/>
-              </a:rPr>
-              <a:t>★ </a:t>
-            </a:r>
-            <a:r>
-              <a:rPr sz="2000" b="1">
-                <a:solidFill>
-                  <a:srgbClr val="FFFFFF"/>
-                </a:solidFill>
-                <a:latin typeface="Funnel Display"/>
-              </a:rPr>
-              <a:t>starbem</a:t>
-            </a:r>
-          </a:p>
-        </p:txBody>
-      </p:sp>
-      <p:sp>
-        <p:nvSpPr>
-          <p:cNvPr id="4" name="TextBox 3"/>
-          <p:cNvSpPr txBox="1"/>
-          <p:nvPr/>
-        </p:nvSpPr>
-        <p:spPr>
-          <a:xfrm>
-            <a:off x="5486400" y="182880"/>
-            <a:ext cx="6217920" cy="548640"/>
-          </a:xfrm>
-          <a:prstGeom prst="rect">
-            <a:avLst/>
-          </a:prstGeom>
-          <a:noFill/>
-        </p:spPr>
-        <p:txBody>
-          <a:bodyPr wrap="square" anchor="ctr">
-            <a:spAutoFit/>
-          </a:bodyPr>
-          <a:lstStyle/>
-          <a:p>
             <a:pPr algn="ctr"/>
             <a:r>
               <a:rPr sz="1500" b="1">
@@ -4301,7 +4244,7 @@
         </p:nvSpPr>
         <p:spPr>
           <a:xfrm>
-            <a:off x="548640" y="2423160"/>
+            <a:off x="548640" y="3031490"/>
             <a:ext cx="11091672" cy="457200"/>
           </a:xfrm>
           <a:prstGeom prst="roundRect">
@@ -4347,7 +4290,7 @@
         </p:nvSpPr>
         <p:spPr>
           <a:xfrm>
-            <a:off x="777240" y="2423160"/>
+            <a:off x="777240" y="3031490"/>
             <a:ext cx="10634472" cy="457200"/>
           </a:xfrm>
           <a:prstGeom prst="rect">
@@ -4381,8 +4324,8 @@
         </p:nvSpPr>
         <p:spPr>
           <a:xfrm>
-            <a:off x="548640" y="2926080"/>
-            <a:ext cx="11091672" cy="3154680"/>
+            <a:off x="548640" y="3534410"/>
+            <a:ext cx="11091672" cy="2166620"/>
           </a:xfrm>
           <a:prstGeom prst="roundRect">
             <a:avLst>
@@ -4429,8 +4372,8 @@
         </p:nvSpPr>
         <p:spPr>
           <a:xfrm>
-            <a:off x="868680" y="3154680"/>
-            <a:ext cx="10424160" cy="2697480"/>
+            <a:off x="868680" y="3772154"/>
+            <a:ext cx="10424160" cy="1755140"/>
           </a:xfrm>
           <a:prstGeom prst="rect">
             <a:avLst/>
@@ -4733,16 +4676,40 @@
           </a:p>
         </p:txBody>
       </p:sp>
-      <p:sp>
-        <p:nvSpPr>
-          <p:cNvPr id="3" name="TextBox 2"/>
+      <p:pic>
+        <p:nvPicPr>
+          <p:cNvPr id="3" name="Picture 2" descr="starbem-logo-white.png"/>
+          <p:cNvPicPr>
+            <a:picLocks noChangeAspect="1"/>
+          </p:cNvPicPr>
+          <p:nvPr/>
+        </p:nvPicPr>
+        <p:blipFill>
+          <a:blip r:embed="rId2"/>
+          <a:stretch>
+            <a:fillRect/>
+          </a:stretch>
+        </p:blipFill>
+        <p:spPr>
+          <a:xfrm>
+            <a:off x="548640" y="265176"/>
+            <a:ext cx="1449238" cy="384048"/>
+          </a:xfrm>
+          <a:prstGeom prst="rect">
+            <a:avLst/>
+          </a:prstGeom>
+        </p:spPr>
+      </p:pic>
+      <p:sp>
+        <p:nvSpPr>
+          <p:cNvPr id="4" name="TextBox 3"/>
           <p:cNvSpPr txBox="1"/>
           <p:nvPr/>
         </p:nvSpPr>
         <p:spPr>
           <a:xfrm>
-            <a:off x="502920" y="182880"/>
-            <a:ext cx="4114800" cy="548640"/>
+            <a:off x="5486400" y="182880"/>
+            <a:ext cx="6217920" cy="548640"/>
           </a:xfrm>
           <a:prstGeom prst="rect">
             <a:avLst/>
@@ -4755,49 +4722,6 @@
           </a:bodyPr>
           <a:lstStyle/>
           <a:p>
-            <a:r>
-              <a:rPr sz="2200" b="1">
-                <a:solidFill>
-                  <a:srgbClr val="FFFFFF"/>
-                </a:solidFill>
-                <a:latin typeface="Calibri"/>
-              </a:rPr>
-              <a:t>★ </a:t>
-            </a:r>
-            <a:r>
-              <a:rPr sz="2000" b="1">
-                <a:solidFill>
-                  <a:srgbClr val="FFFFFF"/>
-                </a:solidFill>
-                <a:latin typeface="Funnel Display"/>
-              </a:rPr>
-              <a:t>starbem</a:t>
-            </a:r>
-          </a:p>
-        </p:txBody>
-      </p:sp>
-      <p:sp>
-        <p:nvSpPr>
-          <p:cNvPr id="4" name="TextBox 3"/>
-          <p:cNvSpPr txBox="1"/>
-          <p:nvPr/>
-        </p:nvSpPr>
-        <p:spPr>
-          <a:xfrm>
-            <a:off x="5486400" y="182880"/>
-            <a:ext cx="6217920" cy="548640"/>
-          </a:xfrm>
-          <a:prstGeom prst="rect">
-            <a:avLst/>
-          </a:prstGeom>
-          <a:noFill/>
-        </p:spPr>
-        <p:txBody>
-          <a:bodyPr wrap="square" anchor="ctr">
-            <a:spAutoFit/>
-          </a:bodyPr>
-          <a:lstStyle/>
-          <a:p>
             <a:pPr algn="ctr"/>
             <a:r>
               <a:rPr sz="1500" b="1">
@@ -4853,8 +4777,8 @@
         </p:nvSpPr>
         <p:spPr>
           <a:xfrm>
-            <a:off x="548640" y="2423160"/>
-            <a:ext cx="11091672" cy="3657600"/>
+            <a:off x="548640" y="3303016"/>
+            <a:ext cx="11091672" cy="2126488"/>
           </a:xfrm>
           <a:prstGeom prst="roundRect">
             <a:avLst>
@@ -4901,8 +4825,8 @@
         </p:nvSpPr>
         <p:spPr>
           <a:xfrm>
-            <a:off x="868680" y="2697479"/>
-            <a:ext cx="5120640" cy="3108960"/>
+            <a:off x="868680" y="3559048"/>
+            <a:ext cx="5120640" cy="1669288"/>
           </a:xfrm>
           <a:prstGeom prst="rect">
             <a:avLst/>
@@ -5045,8 +4969,8 @@
         </p:nvSpPr>
         <p:spPr>
           <a:xfrm>
-            <a:off x="6172200" y="2697479"/>
-            <a:ext cx="5120640" cy="3108960"/>
+            <a:off x="6172200" y="3559048"/>
+            <a:ext cx="5120640" cy="1669288"/>
           </a:xfrm>
           <a:prstGeom prst="rect">
             <a:avLst/>
@@ -5330,16 +5254,40 @@
           </a:p>
         </p:txBody>
       </p:sp>
-      <p:sp>
-        <p:nvSpPr>
-          <p:cNvPr id="3" name="TextBox 2"/>
+      <p:pic>
+        <p:nvPicPr>
+          <p:cNvPr id="3" name="Picture 2" descr="starbem-logo-white.png"/>
+          <p:cNvPicPr>
+            <a:picLocks noChangeAspect="1"/>
+          </p:cNvPicPr>
+          <p:nvPr/>
+        </p:nvPicPr>
+        <p:blipFill>
+          <a:blip r:embed="rId2"/>
+          <a:stretch>
+            <a:fillRect/>
+          </a:stretch>
+        </p:blipFill>
+        <p:spPr>
+          <a:xfrm>
+            <a:off x="548640" y="265176"/>
+            <a:ext cx="1449238" cy="384048"/>
+          </a:xfrm>
+          <a:prstGeom prst="rect">
+            <a:avLst/>
+          </a:prstGeom>
+        </p:spPr>
+      </p:pic>
+      <p:sp>
+        <p:nvSpPr>
+          <p:cNvPr id="4" name="TextBox 3"/>
           <p:cNvSpPr txBox="1"/>
           <p:nvPr/>
         </p:nvSpPr>
         <p:spPr>
           <a:xfrm>
-            <a:off x="502920" y="182880"/>
-            <a:ext cx="4114800" cy="548640"/>
+            <a:off x="5486400" y="182880"/>
+            <a:ext cx="6217920" cy="548640"/>
           </a:xfrm>
           <a:prstGeom prst="rect">
             <a:avLst/>
@@ -5352,49 +5300,6 @@
           </a:bodyPr>
           <a:lstStyle/>
           <a:p>
-            <a:r>
-              <a:rPr sz="2200" b="1">
-                <a:solidFill>
-                  <a:srgbClr val="FFFFFF"/>
-                </a:solidFill>
-                <a:latin typeface="Calibri"/>
-              </a:rPr>
-              <a:t>★ </a:t>
-            </a:r>
-            <a:r>
-              <a:rPr sz="2000" b="1">
-                <a:solidFill>
-                  <a:srgbClr val="FFFFFF"/>
-                </a:solidFill>
-                <a:latin typeface="Funnel Display"/>
-              </a:rPr>
-              <a:t>starbem</a:t>
-            </a:r>
-          </a:p>
-        </p:txBody>
-      </p:sp>
-      <p:sp>
-        <p:nvSpPr>
-          <p:cNvPr id="4" name="TextBox 3"/>
-          <p:cNvSpPr txBox="1"/>
-          <p:nvPr/>
-        </p:nvSpPr>
-        <p:spPr>
-          <a:xfrm>
-            <a:off x="5486400" y="182880"/>
-            <a:ext cx="6217920" cy="548640"/>
-          </a:xfrm>
-          <a:prstGeom prst="rect">
-            <a:avLst/>
-          </a:prstGeom>
-          <a:noFill/>
-        </p:spPr>
-        <p:txBody>
-          <a:bodyPr wrap="square" anchor="ctr">
-            <a:spAutoFit/>
-          </a:bodyPr>
-          <a:lstStyle/>
-          <a:p>
             <a:pPr algn="ctr"/>
             <a:r>
               <a:rPr sz="1500" b="1">
@@ -5450,7 +5355,7 @@
         </p:nvSpPr>
         <p:spPr>
           <a:xfrm>
-            <a:off x="548640" y="2423160"/>
+            <a:off x="548640" y="2706878"/>
             <a:ext cx="5303520" cy="457200"/>
           </a:xfrm>
           <a:prstGeom prst="roundRect">
@@ -5496,7 +5401,7 @@
         </p:nvSpPr>
         <p:spPr>
           <a:xfrm>
-            <a:off x="777240" y="2423160"/>
+            <a:off x="777240" y="2706878"/>
             <a:ext cx="4846320" cy="457200"/>
           </a:xfrm>
           <a:prstGeom prst="rect">
@@ -5530,8 +5435,8 @@
         </p:nvSpPr>
         <p:spPr>
           <a:xfrm>
-            <a:off x="548640" y="2926080"/>
-            <a:ext cx="5303520" cy="3154680"/>
+            <a:off x="548640" y="3209798"/>
+            <a:ext cx="5303520" cy="2815844"/>
           </a:xfrm>
           <a:prstGeom prst="roundRect">
             <a:avLst>
@@ -5578,8 +5483,8 @@
         </p:nvSpPr>
         <p:spPr>
           <a:xfrm>
-            <a:off x="868680" y="3154680"/>
-            <a:ext cx="4663440" cy="2697480"/>
+            <a:off x="868680" y="3447541"/>
+            <a:ext cx="4663440" cy="2404364"/>
           </a:xfrm>
           <a:prstGeom prst="rect">
             <a:avLst/>
@@ -5833,7 +5738,7 @@
         </p:nvSpPr>
         <p:spPr>
           <a:xfrm>
-            <a:off x="6336792" y="2423160"/>
+            <a:off x="6336792" y="2706878"/>
             <a:ext cx="5303520" cy="457200"/>
           </a:xfrm>
           <a:prstGeom prst="roundRect">
@@ -5879,7 +5784,7 @@
         </p:nvSpPr>
         <p:spPr>
           <a:xfrm>
-            <a:off x="6565392" y="2423160"/>
+            <a:off x="6565392" y="2706878"/>
             <a:ext cx="4846320" cy="457200"/>
           </a:xfrm>
           <a:prstGeom prst="rect">
@@ -5913,8 +5818,8 @@
         </p:nvSpPr>
         <p:spPr>
           <a:xfrm>
-            <a:off x="6336792" y="2926080"/>
-            <a:ext cx="5303520" cy="3154680"/>
+            <a:off x="6336792" y="3209798"/>
+            <a:ext cx="5303520" cy="2815844"/>
           </a:xfrm>
           <a:prstGeom prst="roundRect">
             <a:avLst>
@@ -5961,8 +5866,8 @@
         </p:nvSpPr>
         <p:spPr>
           <a:xfrm>
-            <a:off x="6656831" y="3154680"/>
-            <a:ext cx="4663440" cy="2697480"/>
+            <a:off x="6656831" y="3447541"/>
+            <a:ext cx="4663440" cy="2404364"/>
           </a:xfrm>
           <a:prstGeom prst="rect">
             <a:avLst/>
@@ -6201,16 +6106,40 @@
           </a:p>
         </p:txBody>
       </p:sp>
-      <p:sp>
-        <p:nvSpPr>
-          <p:cNvPr id="3" name="TextBox 2"/>
+      <p:pic>
+        <p:nvPicPr>
+          <p:cNvPr id="3" name="Picture 2" descr="starbem-logo-white.png"/>
+          <p:cNvPicPr>
+            <a:picLocks noChangeAspect="1"/>
+          </p:cNvPicPr>
+          <p:nvPr/>
+        </p:nvPicPr>
+        <p:blipFill>
+          <a:blip r:embed="rId2"/>
+          <a:stretch>
+            <a:fillRect/>
+          </a:stretch>
+        </p:blipFill>
+        <p:spPr>
+          <a:xfrm>
+            <a:off x="548640" y="265176"/>
+            <a:ext cx="1449238" cy="384048"/>
+          </a:xfrm>
+          <a:prstGeom prst="rect">
+            <a:avLst/>
+          </a:prstGeom>
+        </p:spPr>
+      </p:pic>
+      <p:sp>
+        <p:nvSpPr>
+          <p:cNvPr id="4" name="TextBox 3"/>
           <p:cNvSpPr txBox="1"/>
           <p:nvPr/>
         </p:nvSpPr>
         <p:spPr>
           <a:xfrm>
-            <a:off x="502920" y="182880"/>
-            <a:ext cx="4114800" cy="548640"/>
+            <a:off x="5486400" y="182880"/>
+            <a:ext cx="6217920" cy="548640"/>
           </a:xfrm>
           <a:prstGeom prst="rect">
             <a:avLst/>
@@ -6223,49 +6152,6 @@
           </a:bodyPr>
           <a:lstStyle/>
           <a:p>
-            <a:r>
-              <a:rPr sz="2200" b="1">
-                <a:solidFill>
-                  <a:srgbClr val="FFFFFF"/>
-                </a:solidFill>
-                <a:latin typeface="Calibri"/>
-              </a:rPr>
-              <a:t>★ </a:t>
-            </a:r>
-            <a:r>
-              <a:rPr sz="2000" b="1">
-                <a:solidFill>
-                  <a:srgbClr val="FFFFFF"/>
-                </a:solidFill>
-                <a:latin typeface="Funnel Display"/>
-              </a:rPr>
-              <a:t>starbem</a:t>
-            </a:r>
-          </a:p>
-        </p:txBody>
-      </p:sp>
-      <p:sp>
-        <p:nvSpPr>
-          <p:cNvPr id="4" name="TextBox 3"/>
-          <p:cNvSpPr txBox="1"/>
-          <p:nvPr/>
-        </p:nvSpPr>
-        <p:spPr>
-          <a:xfrm>
-            <a:off x="5486400" y="182880"/>
-            <a:ext cx="6217920" cy="548640"/>
-          </a:xfrm>
-          <a:prstGeom prst="rect">
-            <a:avLst/>
-          </a:prstGeom>
-          <a:noFill/>
-        </p:spPr>
-        <p:txBody>
-          <a:bodyPr wrap="square" anchor="ctr">
-            <a:spAutoFit/>
-          </a:bodyPr>
-          <a:lstStyle/>
-          <a:p>
             <a:pPr algn="ctr"/>
             <a:r>
               <a:rPr sz="1500" b="1">
@@ -6321,7 +6207,7 @@
         </p:nvSpPr>
         <p:spPr>
           <a:xfrm>
-            <a:off x="548640" y="2423160"/>
+            <a:off x="548640" y="3197860"/>
             <a:ext cx="11091672" cy="457200"/>
           </a:xfrm>
           <a:prstGeom prst="roundRect">
@@ -6367,7 +6253,7 @@
         </p:nvSpPr>
         <p:spPr>
           <a:xfrm>
-            <a:off x="777240" y="2423160"/>
+            <a:off x="777240" y="3197860"/>
             <a:ext cx="10634472" cy="457200"/>
           </a:xfrm>
           <a:prstGeom prst="rect">
@@ -6401,8 +6287,8 @@
         </p:nvSpPr>
         <p:spPr>
           <a:xfrm>
-            <a:off x="548640" y="2926080"/>
-            <a:ext cx="11091672" cy="3154680"/>
+            <a:off x="548640" y="3700780"/>
+            <a:ext cx="11091672" cy="1833880"/>
           </a:xfrm>
           <a:prstGeom prst="roundRect">
             <a:avLst>
@@ -6449,8 +6335,8 @@
         </p:nvSpPr>
         <p:spPr>
           <a:xfrm>
-            <a:off x="868680" y="3154680"/>
-            <a:ext cx="10424160" cy="2697480"/>
+            <a:off x="868680" y="3938524"/>
+            <a:ext cx="10424160" cy="1422400"/>
           </a:xfrm>
           <a:prstGeom prst="rect">
             <a:avLst/>
@@ -6698,49 +6584,30 @@
           </a:p>
         </p:txBody>
       </p:sp>
-      <p:sp>
-        <p:nvSpPr>
-          <p:cNvPr id="3" name="TextBox 2"/>
-          <p:cNvSpPr txBox="1"/>
-          <p:nvPr/>
-        </p:nvSpPr>
-        <p:spPr>
-          <a:xfrm>
-            <a:off x="502920" y="182880"/>
-            <a:ext cx="4114800" cy="548640"/>
-          </a:xfrm>
-          <a:prstGeom prst="rect">
-            <a:avLst/>
-          </a:prstGeom>
-          <a:noFill/>
-        </p:spPr>
-        <p:txBody>
-          <a:bodyPr wrap="square" anchor="ctr">
-            <a:spAutoFit/>
-          </a:bodyPr>
-          <a:lstStyle/>
-          <a:p>
-            <a:r>
-              <a:rPr sz="2200" b="1">
-                <a:solidFill>
-                  <a:srgbClr val="FFFFFF"/>
-                </a:solidFill>
-                <a:latin typeface="Calibri"/>
-              </a:rPr>
-              <a:t>★ </a:t>
-            </a:r>
-            <a:r>
-              <a:rPr sz="2000" b="1">
-                <a:solidFill>
-                  <a:srgbClr val="FFFFFF"/>
-                </a:solidFill>
-                <a:latin typeface="Funnel Display"/>
-              </a:rPr>
-              <a:t>starbem</a:t>
-            </a:r>
-          </a:p>
-        </p:txBody>
-      </p:sp>
+      <p:pic>
+        <p:nvPicPr>
+          <p:cNvPr id="3" name="Picture 2" descr="starbem-logo-white.png"/>
+          <p:cNvPicPr>
+            <a:picLocks noChangeAspect="1"/>
+          </p:cNvPicPr>
+          <p:nvPr/>
+        </p:nvPicPr>
+        <p:blipFill>
+          <a:blip r:embed="rId2"/>
+          <a:stretch>
+            <a:fillRect/>
+          </a:stretch>
+        </p:blipFill>
+        <p:spPr>
+          <a:xfrm>
+            <a:off x="548640" y="265176"/>
+            <a:ext cx="1449238" cy="384048"/>
+          </a:xfrm>
+          <a:prstGeom prst="rect">
+            <a:avLst/>
+          </a:prstGeom>
+        </p:spPr>
+      </p:pic>
       <p:sp>
         <p:nvSpPr>
           <p:cNvPr id="4" name="TextBox 3"/>
@@ -7775,49 +7642,30 @@
           </a:p>
         </p:txBody>
       </p:sp>
-      <p:sp>
-        <p:nvSpPr>
-          <p:cNvPr id="3" name="TextBox 2"/>
-          <p:cNvSpPr txBox="1"/>
-          <p:nvPr/>
-        </p:nvSpPr>
-        <p:spPr>
-          <a:xfrm>
-            <a:off x="502920" y="182880"/>
-            <a:ext cx="4114800" cy="548640"/>
-          </a:xfrm>
-          <a:prstGeom prst="rect">
-            <a:avLst/>
-          </a:prstGeom>
-          <a:noFill/>
-        </p:spPr>
-        <p:txBody>
-          <a:bodyPr wrap="square" anchor="ctr">
-            <a:spAutoFit/>
-          </a:bodyPr>
-          <a:lstStyle/>
-          <a:p>
-            <a:r>
-              <a:rPr sz="2200" b="1">
-                <a:solidFill>
-                  <a:srgbClr val="FFFFFF"/>
-                </a:solidFill>
-                <a:latin typeface="Calibri"/>
-              </a:rPr>
-              <a:t>★ </a:t>
-            </a:r>
-            <a:r>
-              <a:rPr sz="2000" b="1">
-                <a:solidFill>
-                  <a:srgbClr val="FFFFFF"/>
-                </a:solidFill>
-                <a:latin typeface="Funnel Display"/>
-              </a:rPr>
-              <a:t>starbem</a:t>
-            </a:r>
-          </a:p>
-        </p:txBody>
-      </p:sp>
+      <p:pic>
+        <p:nvPicPr>
+          <p:cNvPr id="3" name="Picture 2" descr="starbem-logo-white.png"/>
+          <p:cNvPicPr>
+            <a:picLocks noChangeAspect="1"/>
+          </p:cNvPicPr>
+          <p:nvPr/>
+        </p:nvPicPr>
+        <p:blipFill>
+          <a:blip r:embed="rId2"/>
+          <a:stretch>
+            <a:fillRect/>
+          </a:stretch>
+        </p:blipFill>
+        <p:spPr>
+          <a:xfrm>
+            <a:off x="548640" y="265176"/>
+            <a:ext cx="1449238" cy="384048"/>
+          </a:xfrm>
+          <a:prstGeom prst="rect">
+            <a:avLst/>
+          </a:prstGeom>
+        </p:spPr>
+      </p:pic>
       <p:sp>
         <p:nvSpPr>
           <p:cNvPr id="4" name="TextBox 3"/>
@@ -8480,16 +8328,40 @@
           </a:p>
         </p:txBody>
       </p:sp>
-      <p:sp>
-        <p:nvSpPr>
-          <p:cNvPr id="3" name="TextBox 2"/>
+      <p:pic>
+        <p:nvPicPr>
+          <p:cNvPr id="3" name="Picture 2" descr="starbem-logo-white.png"/>
+          <p:cNvPicPr>
+            <a:picLocks noChangeAspect="1"/>
+          </p:cNvPicPr>
+          <p:nvPr/>
+        </p:nvPicPr>
+        <p:blipFill>
+          <a:blip r:embed="rId2"/>
+          <a:stretch>
+            <a:fillRect/>
+          </a:stretch>
+        </p:blipFill>
+        <p:spPr>
+          <a:xfrm>
+            <a:off x="548640" y="265176"/>
+            <a:ext cx="1449238" cy="384048"/>
+          </a:xfrm>
+          <a:prstGeom prst="rect">
+            <a:avLst/>
+          </a:prstGeom>
+        </p:spPr>
+      </p:pic>
+      <p:sp>
+        <p:nvSpPr>
+          <p:cNvPr id="4" name="TextBox 3"/>
           <p:cNvSpPr txBox="1"/>
           <p:nvPr/>
         </p:nvSpPr>
         <p:spPr>
           <a:xfrm>
-            <a:off x="502920" y="182880"/>
-            <a:ext cx="4114800" cy="548640"/>
+            <a:off x="5486400" y="182880"/>
+            <a:ext cx="6217920" cy="548640"/>
           </a:xfrm>
           <a:prstGeom prst="rect">
             <a:avLst/>
@@ -8502,49 +8374,6 @@
           </a:bodyPr>
           <a:lstStyle/>
           <a:p>
-            <a:r>
-              <a:rPr sz="2200" b="1">
-                <a:solidFill>
-                  <a:srgbClr val="FFFFFF"/>
-                </a:solidFill>
-                <a:latin typeface="Calibri"/>
-              </a:rPr>
-              <a:t>★ </a:t>
-            </a:r>
-            <a:r>
-              <a:rPr sz="2000" b="1">
-                <a:solidFill>
-                  <a:srgbClr val="FFFFFF"/>
-                </a:solidFill>
-                <a:latin typeface="Funnel Display"/>
-              </a:rPr>
-              <a:t>starbem</a:t>
-            </a:r>
-          </a:p>
-        </p:txBody>
-      </p:sp>
-      <p:sp>
-        <p:nvSpPr>
-          <p:cNvPr id="4" name="TextBox 3"/>
-          <p:cNvSpPr txBox="1"/>
-          <p:nvPr/>
-        </p:nvSpPr>
-        <p:spPr>
-          <a:xfrm>
-            <a:off x="5486400" y="182880"/>
-            <a:ext cx="6217920" cy="548640"/>
-          </a:xfrm>
-          <a:prstGeom prst="rect">
-            <a:avLst/>
-          </a:prstGeom>
-          <a:noFill/>
-        </p:spPr>
-        <p:txBody>
-          <a:bodyPr wrap="square" anchor="ctr">
-            <a:spAutoFit/>
-          </a:bodyPr>
-          <a:lstStyle/>
-          <a:p>
             <a:pPr algn="ctr"/>
             <a:r>
               <a:rPr sz="1500" b="1">
@@ -8600,7 +8429,7 @@
         </p:nvSpPr>
         <p:spPr>
           <a:xfrm>
-            <a:off x="548640" y="2423160"/>
+            <a:off x="548640" y="2860802"/>
             <a:ext cx="11091672" cy="457200"/>
           </a:xfrm>
           <a:prstGeom prst="roundRect">
@@ -8646,7 +8475,7 @@
         </p:nvSpPr>
         <p:spPr>
           <a:xfrm>
-            <a:off x="777240" y="2423160"/>
+            <a:off x="777240" y="2860802"/>
             <a:ext cx="10634472" cy="457200"/>
           </a:xfrm>
           <a:prstGeom prst="rect">
@@ -8680,8 +8509,8 @@
         </p:nvSpPr>
         <p:spPr>
           <a:xfrm>
-            <a:off x="548640" y="2926080"/>
-            <a:ext cx="11091672" cy="3154680"/>
+            <a:off x="548640" y="3363722"/>
+            <a:ext cx="11091672" cy="2507996"/>
           </a:xfrm>
           <a:prstGeom prst="roundRect">
             <a:avLst>
@@ -8728,8 +8557,8 @@
         </p:nvSpPr>
         <p:spPr>
           <a:xfrm>
-            <a:off x="868680" y="3154680"/>
-            <a:ext cx="10424160" cy="2697480"/>
+            <a:off x="868680" y="3601466"/>
+            <a:ext cx="10424160" cy="2096515"/>
           </a:xfrm>
           <a:prstGeom prst="rect">
             <a:avLst/>
@@ -9059,49 +8888,30 @@
           </a:p>
         </p:txBody>
       </p:sp>
-      <p:sp>
-        <p:nvSpPr>
-          <p:cNvPr id="3" name="TextBox 2"/>
-          <p:cNvSpPr txBox="1"/>
-          <p:nvPr/>
-        </p:nvSpPr>
-        <p:spPr>
-          <a:xfrm>
-            <a:off x="502920" y="182880"/>
-            <a:ext cx="4114800" cy="548640"/>
-          </a:xfrm>
-          <a:prstGeom prst="rect">
-            <a:avLst/>
-          </a:prstGeom>
-          <a:noFill/>
-        </p:spPr>
-        <p:txBody>
-          <a:bodyPr wrap="square" anchor="ctr">
-            <a:spAutoFit/>
-          </a:bodyPr>
-          <a:lstStyle/>
-          <a:p>
-            <a:r>
-              <a:rPr sz="2200" b="1">
-                <a:solidFill>
-                  <a:srgbClr val="FFFFFF"/>
-                </a:solidFill>
-                <a:latin typeface="Calibri"/>
-              </a:rPr>
-              <a:t>★ </a:t>
-            </a:r>
-            <a:r>
-              <a:rPr sz="2000" b="1">
-                <a:solidFill>
-                  <a:srgbClr val="FFFFFF"/>
-                </a:solidFill>
-                <a:latin typeface="Funnel Display"/>
-              </a:rPr>
-              <a:t>starbem</a:t>
-            </a:r>
-          </a:p>
-        </p:txBody>
-      </p:sp>
+      <p:pic>
+        <p:nvPicPr>
+          <p:cNvPr id="3" name="Picture 2" descr="starbem-logo-white.png"/>
+          <p:cNvPicPr>
+            <a:picLocks noChangeAspect="1"/>
+          </p:cNvPicPr>
+          <p:nvPr/>
+        </p:nvPicPr>
+        <p:blipFill>
+          <a:blip r:embed="rId2"/>
+          <a:stretch>
+            <a:fillRect/>
+          </a:stretch>
+        </p:blipFill>
+        <p:spPr>
+          <a:xfrm>
+            <a:off x="548640" y="265176"/>
+            <a:ext cx="1449238" cy="384048"/>
+          </a:xfrm>
+          <a:prstGeom prst="rect">
+            <a:avLst/>
+          </a:prstGeom>
+        </p:spPr>
+      </p:pic>
       <p:sp>
         <p:nvSpPr>
           <p:cNvPr id="4" name="TextBox 3"/>
@@ -9913,49 +9723,30 @@
           </a:p>
         </p:txBody>
       </p:sp>
-      <p:sp>
-        <p:nvSpPr>
-          <p:cNvPr id="3" name="TextBox 2"/>
-          <p:cNvSpPr txBox="1"/>
-          <p:nvPr/>
-        </p:nvSpPr>
-        <p:spPr>
-          <a:xfrm>
-            <a:off x="502920" y="182880"/>
-            <a:ext cx="4114800" cy="548640"/>
-          </a:xfrm>
-          <a:prstGeom prst="rect">
-            <a:avLst/>
-          </a:prstGeom>
-          <a:noFill/>
-        </p:spPr>
-        <p:txBody>
-          <a:bodyPr wrap="square" anchor="ctr">
-            <a:spAutoFit/>
-          </a:bodyPr>
-          <a:lstStyle/>
-          <a:p>
-            <a:r>
-              <a:rPr sz="2200" b="1">
-                <a:solidFill>
-                  <a:srgbClr val="FFFFFF"/>
-                </a:solidFill>
-                <a:latin typeface="Calibri"/>
-              </a:rPr>
-              <a:t>★ </a:t>
-            </a:r>
-            <a:r>
-              <a:rPr sz="2000" b="1">
-                <a:solidFill>
-                  <a:srgbClr val="FFFFFF"/>
-                </a:solidFill>
-                <a:latin typeface="Funnel Display"/>
-              </a:rPr>
-              <a:t>starbem</a:t>
-            </a:r>
-          </a:p>
-        </p:txBody>
-      </p:sp>
+      <p:pic>
+        <p:nvPicPr>
+          <p:cNvPr id="3" name="Picture 2" descr="starbem-logo-white.png"/>
+          <p:cNvPicPr>
+            <a:picLocks noChangeAspect="1"/>
+          </p:cNvPicPr>
+          <p:nvPr/>
+        </p:nvPicPr>
+        <p:blipFill>
+          <a:blip r:embed="rId2"/>
+          <a:stretch>
+            <a:fillRect/>
+          </a:stretch>
+        </p:blipFill>
+        <p:spPr>
+          <a:xfrm>
+            <a:off x="548640" y="265176"/>
+            <a:ext cx="1449238" cy="384048"/>
+          </a:xfrm>
+          <a:prstGeom prst="rect">
+            <a:avLst/>
+          </a:prstGeom>
+        </p:spPr>
+      </p:pic>
       <p:sp>
         <p:nvSpPr>
           <p:cNvPr id="4" name="TextBox 3"/>
@@ -11024,49 +10815,30 @@
           </a:p>
         </p:txBody>
       </p:sp>
-      <p:sp>
-        <p:nvSpPr>
-          <p:cNvPr id="3" name="TextBox 2"/>
-          <p:cNvSpPr txBox="1"/>
-          <p:nvPr/>
-        </p:nvSpPr>
-        <p:spPr>
-          <a:xfrm>
-            <a:off x="502920" y="182880"/>
-            <a:ext cx="4114800" cy="548640"/>
-          </a:xfrm>
-          <a:prstGeom prst="rect">
-            <a:avLst/>
-          </a:prstGeom>
-          <a:noFill/>
-        </p:spPr>
-        <p:txBody>
-          <a:bodyPr wrap="square" anchor="ctr">
-            <a:spAutoFit/>
-          </a:bodyPr>
-          <a:lstStyle/>
-          <a:p>
-            <a:r>
-              <a:rPr sz="2200" b="1">
-                <a:solidFill>
-                  <a:srgbClr val="FFFFFF"/>
-                </a:solidFill>
-                <a:latin typeface="Calibri"/>
-              </a:rPr>
-              <a:t>★ </a:t>
-            </a:r>
-            <a:r>
-              <a:rPr sz="2000" b="1">
-                <a:solidFill>
-                  <a:srgbClr val="FFFFFF"/>
-                </a:solidFill>
-                <a:latin typeface="Funnel Display"/>
-              </a:rPr>
-              <a:t>starbem</a:t>
-            </a:r>
-          </a:p>
-        </p:txBody>
-      </p:sp>
+      <p:pic>
+        <p:nvPicPr>
+          <p:cNvPr id="3" name="Picture 2" descr="starbem-logo-white.png"/>
+          <p:cNvPicPr>
+            <a:picLocks noChangeAspect="1"/>
+          </p:cNvPicPr>
+          <p:nvPr/>
+        </p:nvPicPr>
+        <p:blipFill>
+          <a:blip r:embed="rId2"/>
+          <a:stretch>
+            <a:fillRect/>
+          </a:stretch>
+        </p:blipFill>
+        <p:spPr>
+          <a:xfrm>
+            <a:off x="548640" y="265176"/>
+            <a:ext cx="1449238" cy="384048"/>
+          </a:xfrm>
+          <a:prstGeom prst="rect">
+            <a:avLst/>
+          </a:prstGeom>
+        </p:spPr>
+      </p:pic>
       <p:sp>
         <p:nvSpPr>
           <p:cNvPr id="4" name="TextBox 3"/>
@@ -11589,16 +11361,40 @@
           </a:p>
         </p:txBody>
       </p:sp>
-      <p:sp>
-        <p:nvSpPr>
-          <p:cNvPr id="3" name="TextBox 2"/>
+      <p:pic>
+        <p:nvPicPr>
+          <p:cNvPr id="3" name="Picture 2" descr="starbem-logo-white.png"/>
+          <p:cNvPicPr>
+            <a:picLocks noChangeAspect="1"/>
+          </p:cNvPicPr>
+          <p:nvPr/>
+        </p:nvPicPr>
+        <p:blipFill>
+          <a:blip r:embed="rId2"/>
+          <a:stretch>
+            <a:fillRect/>
+          </a:stretch>
+        </p:blipFill>
+        <p:spPr>
+          <a:xfrm>
+            <a:off x="548640" y="265176"/>
+            <a:ext cx="1449238" cy="384048"/>
+          </a:xfrm>
+          <a:prstGeom prst="rect">
+            <a:avLst/>
+          </a:prstGeom>
+        </p:spPr>
+      </p:pic>
+      <p:sp>
+        <p:nvSpPr>
+          <p:cNvPr id="4" name="TextBox 3"/>
           <p:cNvSpPr txBox="1"/>
           <p:nvPr/>
         </p:nvSpPr>
         <p:spPr>
           <a:xfrm>
-            <a:off x="502920" y="182880"/>
-            <a:ext cx="4114800" cy="548640"/>
+            <a:off x="5486400" y="182880"/>
+            <a:ext cx="6217920" cy="548640"/>
           </a:xfrm>
           <a:prstGeom prst="rect">
             <a:avLst/>
@@ -11611,49 +11407,6 @@
           </a:bodyPr>
           <a:lstStyle/>
           <a:p>
-            <a:r>
-              <a:rPr sz="2200" b="1">
-                <a:solidFill>
-                  <a:srgbClr val="FFFFFF"/>
-                </a:solidFill>
-                <a:latin typeface="Calibri"/>
-              </a:rPr>
-              <a:t>★ </a:t>
-            </a:r>
-            <a:r>
-              <a:rPr sz="2000" b="1">
-                <a:solidFill>
-                  <a:srgbClr val="FFFFFF"/>
-                </a:solidFill>
-                <a:latin typeface="Funnel Display"/>
-              </a:rPr>
-              <a:t>starbem</a:t>
-            </a:r>
-          </a:p>
-        </p:txBody>
-      </p:sp>
-      <p:sp>
-        <p:nvSpPr>
-          <p:cNvPr id="4" name="TextBox 3"/>
-          <p:cNvSpPr txBox="1"/>
-          <p:nvPr/>
-        </p:nvSpPr>
-        <p:spPr>
-          <a:xfrm>
-            <a:off x="5486400" y="182880"/>
-            <a:ext cx="6217920" cy="548640"/>
-          </a:xfrm>
-          <a:prstGeom prst="rect">
-            <a:avLst/>
-          </a:prstGeom>
-          <a:noFill/>
-        </p:spPr>
-        <p:txBody>
-          <a:bodyPr wrap="square" anchor="ctr">
-            <a:spAutoFit/>
-          </a:bodyPr>
-          <a:lstStyle/>
-          <a:p>
             <a:pPr algn="ctr"/>
             <a:r>
               <a:rPr sz="1500" b="1">
@@ -11709,8 +11462,8 @@
         </p:nvSpPr>
         <p:spPr>
           <a:xfrm>
-            <a:off x="548640" y="2423160"/>
-            <a:ext cx="11091672" cy="3657600"/>
+            <a:off x="548640" y="3408680"/>
+            <a:ext cx="11091672" cy="1915160"/>
           </a:xfrm>
           <a:prstGeom prst="roundRect">
             <a:avLst>
@@ -11757,8 +11510,8 @@
         </p:nvSpPr>
         <p:spPr>
           <a:xfrm>
-            <a:off x="868680" y="2697479"/>
-            <a:ext cx="5120640" cy="3108960"/>
+            <a:off x="868680" y="3664712"/>
+            <a:ext cx="5120640" cy="1457960"/>
           </a:xfrm>
           <a:prstGeom prst="rect">
             <a:avLst/>
@@ -11937,8 +11690,8 @@
         </p:nvSpPr>
         <p:spPr>
           <a:xfrm>
-            <a:off x="6172200" y="2697479"/>
-            <a:ext cx="5120640" cy="3108960"/>
+            <a:off x="6172200" y="3664712"/>
+            <a:ext cx="5120640" cy="1457960"/>
           </a:xfrm>
           <a:prstGeom prst="rect">
             <a:avLst/>
@@ -12167,16 +11920,40 @@
           </a:p>
         </p:txBody>
       </p:sp>
-      <p:sp>
-        <p:nvSpPr>
-          <p:cNvPr id="3" name="TextBox 2"/>
+      <p:pic>
+        <p:nvPicPr>
+          <p:cNvPr id="3" name="Picture 2" descr="starbem-logo-white.png"/>
+          <p:cNvPicPr>
+            <a:picLocks noChangeAspect="1"/>
+          </p:cNvPicPr>
+          <p:nvPr/>
+        </p:nvPicPr>
+        <p:blipFill>
+          <a:blip r:embed="rId2"/>
+          <a:stretch>
+            <a:fillRect/>
+          </a:stretch>
+        </p:blipFill>
+        <p:spPr>
+          <a:xfrm>
+            <a:off x="548640" y="265176"/>
+            <a:ext cx="1449238" cy="384048"/>
+          </a:xfrm>
+          <a:prstGeom prst="rect">
+            <a:avLst/>
+          </a:prstGeom>
+        </p:spPr>
+      </p:pic>
+      <p:sp>
+        <p:nvSpPr>
+          <p:cNvPr id="4" name="TextBox 3"/>
           <p:cNvSpPr txBox="1"/>
           <p:nvPr/>
         </p:nvSpPr>
         <p:spPr>
           <a:xfrm>
-            <a:off x="502920" y="182880"/>
-            <a:ext cx="4114800" cy="548640"/>
+            <a:off x="5486400" y="182880"/>
+            <a:ext cx="6217920" cy="548640"/>
           </a:xfrm>
           <a:prstGeom prst="rect">
             <a:avLst/>
@@ -12189,49 +11966,6 @@
           </a:bodyPr>
           <a:lstStyle/>
           <a:p>
-            <a:r>
-              <a:rPr sz="2200" b="1">
-                <a:solidFill>
-                  <a:srgbClr val="FFFFFF"/>
-                </a:solidFill>
-                <a:latin typeface="Calibri"/>
-              </a:rPr>
-              <a:t>★ </a:t>
-            </a:r>
-            <a:r>
-              <a:rPr sz="2000" b="1">
-                <a:solidFill>
-                  <a:srgbClr val="FFFFFF"/>
-                </a:solidFill>
-                <a:latin typeface="Funnel Display"/>
-              </a:rPr>
-              <a:t>starbem</a:t>
-            </a:r>
-          </a:p>
-        </p:txBody>
-      </p:sp>
-      <p:sp>
-        <p:nvSpPr>
-          <p:cNvPr id="4" name="TextBox 3"/>
-          <p:cNvSpPr txBox="1"/>
-          <p:nvPr/>
-        </p:nvSpPr>
-        <p:spPr>
-          <a:xfrm>
-            <a:off x="5486400" y="182880"/>
-            <a:ext cx="6217920" cy="548640"/>
-          </a:xfrm>
-          <a:prstGeom prst="rect">
-            <a:avLst/>
-          </a:prstGeom>
-          <a:noFill/>
-        </p:spPr>
-        <p:txBody>
-          <a:bodyPr wrap="square" anchor="ctr">
-            <a:spAutoFit/>
-          </a:bodyPr>
-          <a:lstStyle/>
-          <a:p>
             <a:pPr algn="ctr"/>
             <a:r>
               <a:rPr sz="1500" b="1">
@@ -12287,8 +12021,8 @@
         </p:nvSpPr>
         <p:spPr>
           <a:xfrm>
-            <a:off x="548640" y="2423160"/>
-            <a:ext cx="11091672" cy="3657600"/>
+            <a:off x="548640" y="3152902"/>
+            <a:ext cx="11091672" cy="2426716"/>
           </a:xfrm>
           <a:prstGeom prst="roundRect">
             <a:avLst>
@@ -12335,8 +12069,8 @@
         </p:nvSpPr>
         <p:spPr>
           <a:xfrm>
-            <a:off x="868680" y="2697479"/>
-            <a:ext cx="5120640" cy="3108960"/>
+            <a:off x="868680" y="3408934"/>
+            <a:ext cx="5120640" cy="1969516"/>
           </a:xfrm>
           <a:prstGeom prst="rect">
             <a:avLst/>
@@ -12516,8 +12250,8 @@
         </p:nvSpPr>
         <p:spPr>
           <a:xfrm>
-            <a:off x="6172200" y="2697479"/>
-            <a:ext cx="5120640" cy="3108960"/>
+            <a:off x="6172200" y="3408934"/>
+            <a:ext cx="5120640" cy="1969516"/>
           </a:xfrm>
           <a:prstGeom prst="rect">
             <a:avLst/>
@@ -12802,16 +12536,40 @@
           </a:p>
         </p:txBody>
       </p:sp>
-      <p:sp>
-        <p:nvSpPr>
-          <p:cNvPr id="3" name="TextBox 2"/>
+      <p:pic>
+        <p:nvPicPr>
+          <p:cNvPr id="3" name="Picture 2" descr="starbem-logo-white.png"/>
+          <p:cNvPicPr>
+            <a:picLocks noChangeAspect="1"/>
+          </p:cNvPicPr>
+          <p:nvPr/>
+        </p:nvPicPr>
+        <p:blipFill>
+          <a:blip r:embed="rId2"/>
+          <a:stretch>
+            <a:fillRect/>
+          </a:stretch>
+        </p:blipFill>
+        <p:spPr>
+          <a:xfrm>
+            <a:off x="548640" y="265176"/>
+            <a:ext cx="1449238" cy="384048"/>
+          </a:xfrm>
+          <a:prstGeom prst="rect">
+            <a:avLst/>
+          </a:prstGeom>
+        </p:spPr>
+      </p:pic>
+      <p:sp>
+        <p:nvSpPr>
+          <p:cNvPr id="4" name="TextBox 3"/>
           <p:cNvSpPr txBox="1"/>
           <p:nvPr/>
         </p:nvSpPr>
         <p:spPr>
           <a:xfrm>
-            <a:off x="502920" y="182880"/>
-            <a:ext cx="4114800" cy="548640"/>
+            <a:off x="5486400" y="182880"/>
+            <a:ext cx="6217920" cy="548640"/>
           </a:xfrm>
           <a:prstGeom prst="rect">
             <a:avLst/>
@@ -12824,49 +12582,6 @@
           </a:bodyPr>
           <a:lstStyle/>
           <a:p>
-            <a:r>
-              <a:rPr sz="2200" b="1">
-                <a:solidFill>
-                  <a:srgbClr val="FFFFFF"/>
-                </a:solidFill>
-                <a:latin typeface="Calibri"/>
-              </a:rPr>
-              <a:t>★ </a:t>
-            </a:r>
-            <a:r>
-              <a:rPr sz="2000" b="1">
-                <a:solidFill>
-                  <a:srgbClr val="FFFFFF"/>
-                </a:solidFill>
-                <a:latin typeface="Funnel Display"/>
-              </a:rPr>
-              <a:t>starbem</a:t>
-            </a:r>
-          </a:p>
-        </p:txBody>
-      </p:sp>
-      <p:sp>
-        <p:nvSpPr>
-          <p:cNvPr id="4" name="TextBox 3"/>
-          <p:cNvSpPr txBox="1"/>
-          <p:nvPr/>
-        </p:nvSpPr>
-        <p:spPr>
-          <a:xfrm>
-            <a:off x="5486400" y="182880"/>
-            <a:ext cx="6217920" cy="548640"/>
-          </a:xfrm>
-          <a:prstGeom prst="rect">
-            <a:avLst/>
-          </a:prstGeom>
-          <a:noFill/>
-        </p:spPr>
-        <p:txBody>
-          <a:bodyPr wrap="square" anchor="ctr">
-            <a:spAutoFit/>
-          </a:bodyPr>
-          <a:lstStyle/>
-          <a:p>
             <a:pPr algn="ctr"/>
             <a:r>
               <a:rPr sz="1500" b="1">
@@ -12922,8 +12637,8 @@
         </p:nvSpPr>
         <p:spPr>
           <a:xfrm>
-            <a:off x="548640" y="2423160"/>
-            <a:ext cx="11091672" cy="3657600"/>
+            <a:off x="548640" y="3347466"/>
+            <a:ext cx="11091672" cy="2037588"/>
           </a:xfrm>
           <a:prstGeom prst="roundRect">
             <a:avLst>
@@ -12970,8 +12685,8 @@
         </p:nvSpPr>
         <p:spPr>
           <a:xfrm>
-            <a:off x="868680" y="2697479"/>
-            <a:ext cx="5120640" cy="3108960"/>
+            <a:off x="868680" y="3603497"/>
+            <a:ext cx="5120640" cy="1580388"/>
           </a:xfrm>
           <a:prstGeom prst="rect">
             <a:avLst/>
@@ -13123,8 +12838,8 @@
         </p:nvSpPr>
         <p:spPr>
           <a:xfrm>
-            <a:off x="6172200" y="2697479"/>
-            <a:ext cx="5120640" cy="3108960"/>
+            <a:off x="6172200" y="3603497"/>
+            <a:ext cx="5120640" cy="1580388"/>
           </a:xfrm>
           <a:prstGeom prst="rect">
             <a:avLst/>
@@ -13371,16 +13086,40 @@
           </a:p>
         </p:txBody>
       </p:sp>
-      <p:sp>
-        <p:nvSpPr>
-          <p:cNvPr id="3" name="TextBox 2"/>
+      <p:pic>
+        <p:nvPicPr>
+          <p:cNvPr id="3" name="Picture 2" descr="starbem-logo-white.png"/>
+          <p:cNvPicPr>
+            <a:picLocks noChangeAspect="1"/>
+          </p:cNvPicPr>
+          <p:nvPr/>
+        </p:nvPicPr>
+        <p:blipFill>
+          <a:blip r:embed="rId2"/>
+          <a:stretch>
+            <a:fillRect/>
+          </a:stretch>
+        </p:blipFill>
+        <p:spPr>
+          <a:xfrm>
+            <a:off x="548640" y="265176"/>
+            <a:ext cx="1449238" cy="384048"/>
+          </a:xfrm>
+          <a:prstGeom prst="rect">
+            <a:avLst/>
+          </a:prstGeom>
+        </p:spPr>
+      </p:pic>
+      <p:sp>
+        <p:nvSpPr>
+          <p:cNvPr id="4" name="TextBox 3"/>
           <p:cNvSpPr txBox="1"/>
           <p:nvPr/>
         </p:nvSpPr>
         <p:spPr>
           <a:xfrm>
-            <a:off x="502920" y="182880"/>
-            <a:ext cx="4114800" cy="548640"/>
+            <a:off x="5486400" y="182880"/>
+            <a:ext cx="6217920" cy="548640"/>
           </a:xfrm>
           <a:prstGeom prst="rect">
             <a:avLst/>
@@ -13393,49 +13132,6 @@
           </a:bodyPr>
           <a:lstStyle/>
           <a:p>
-            <a:r>
-              <a:rPr sz="2200" b="1">
-                <a:solidFill>
-                  <a:srgbClr val="FFFFFF"/>
-                </a:solidFill>
-                <a:latin typeface="Calibri"/>
-              </a:rPr>
-              <a:t>★ </a:t>
-            </a:r>
-            <a:r>
-              <a:rPr sz="2000" b="1">
-                <a:solidFill>
-                  <a:srgbClr val="FFFFFF"/>
-                </a:solidFill>
-                <a:latin typeface="Funnel Display"/>
-              </a:rPr>
-              <a:t>starbem</a:t>
-            </a:r>
-          </a:p>
-        </p:txBody>
-      </p:sp>
-      <p:sp>
-        <p:nvSpPr>
-          <p:cNvPr id="4" name="TextBox 3"/>
-          <p:cNvSpPr txBox="1"/>
-          <p:nvPr/>
-        </p:nvSpPr>
-        <p:spPr>
-          <a:xfrm>
-            <a:off x="5486400" y="182880"/>
-            <a:ext cx="6217920" cy="548640"/>
-          </a:xfrm>
-          <a:prstGeom prst="rect">
-            <a:avLst/>
-          </a:prstGeom>
-          <a:noFill/>
-        </p:spPr>
-        <p:txBody>
-          <a:bodyPr wrap="square" anchor="ctr">
-            <a:spAutoFit/>
-          </a:bodyPr>
-          <a:lstStyle/>
-          <a:p>
             <a:pPr algn="ctr"/>
             <a:r>
               <a:rPr sz="1500" b="1">
@@ -13491,8 +13187,8 @@
         </p:nvSpPr>
         <p:spPr>
           <a:xfrm>
-            <a:off x="548640" y="2423160"/>
-            <a:ext cx="11091672" cy="3657600"/>
+            <a:off x="548640" y="3453129"/>
+            <a:ext cx="11091672" cy="1826260"/>
           </a:xfrm>
           <a:prstGeom prst="roundRect">
             <a:avLst>
@@ -13539,8 +13235,8 @@
         </p:nvSpPr>
         <p:spPr>
           <a:xfrm>
-            <a:off x="868680" y="2697479"/>
-            <a:ext cx="5120640" cy="3108960"/>
+            <a:off x="868680" y="3709162"/>
+            <a:ext cx="5120640" cy="1369060"/>
           </a:xfrm>
           <a:prstGeom prst="rect">
             <a:avLst/>
@@ -13655,8 +13351,8 @@
         </p:nvSpPr>
         <p:spPr>
           <a:xfrm>
-            <a:off x="6172200" y="2697479"/>
-            <a:ext cx="5120640" cy="3108960"/>
+            <a:off x="6172200" y="3709162"/>
+            <a:ext cx="5120640" cy="1369060"/>
           </a:xfrm>
           <a:prstGeom prst="rect">
             <a:avLst/>
@@ -13903,16 +13599,40 @@
           </a:p>
         </p:txBody>
       </p:sp>
-      <p:sp>
-        <p:nvSpPr>
-          <p:cNvPr id="3" name="TextBox 2"/>
+      <p:pic>
+        <p:nvPicPr>
+          <p:cNvPr id="3" name="Picture 2" descr="starbem-logo-white.png"/>
+          <p:cNvPicPr>
+            <a:picLocks noChangeAspect="1"/>
+          </p:cNvPicPr>
+          <p:nvPr/>
+        </p:nvPicPr>
+        <p:blipFill>
+          <a:blip r:embed="rId2"/>
+          <a:stretch>
+            <a:fillRect/>
+          </a:stretch>
+        </p:blipFill>
+        <p:spPr>
+          <a:xfrm>
+            <a:off x="548640" y="265176"/>
+            <a:ext cx="1449238" cy="384048"/>
+          </a:xfrm>
+          <a:prstGeom prst="rect">
+            <a:avLst/>
+          </a:prstGeom>
+        </p:spPr>
+      </p:pic>
+      <p:sp>
+        <p:nvSpPr>
+          <p:cNvPr id="4" name="TextBox 3"/>
           <p:cNvSpPr txBox="1"/>
           <p:nvPr/>
         </p:nvSpPr>
         <p:spPr>
           <a:xfrm>
-            <a:off x="502920" y="182880"/>
-            <a:ext cx="4114800" cy="548640"/>
+            <a:off x="5486400" y="182880"/>
+            <a:ext cx="6217920" cy="548640"/>
           </a:xfrm>
           <a:prstGeom prst="rect">
             <a:avLst/>
@@ -13925,49 +13645,6 @@
           </a:bodyPr>
           <a:lstStyle/>
           <a:p>
-            <a:r>
-              <a:rPr sz="2200" b="1">
-                <a:solidFill>
-                  <a:srgbClr val="FFFFFF"/>
-                </a:solidFill>
-                <a:latin typeface="Calibri"/>
-              </a:rPr>
-              <a:t>★ </a:t>
-            </a:r>
-            <a:r>
-              <a:rPr sz="2000" b="1">
-                <a:solidFill>
-                  <a:srgbClr val="FFFFFF"/>
-                </a:solidFill>
-                <a:latin typeface="Funnel Display"/>
-              </a:rPr>
-              <a:t>starbem</a:t>
-            </a:r>
-          </a:p>
-        </p:txBody>
-      </p:sp>
-      <p:sp>
-        <p:nvSpPr>
-          <p:cNvPr id="4" name="TextBox 3"/>
-          <p:cNvSpPr txBox="1"/>
-          <p:nvPr/>
-        </p:nvSpPr>
-        <p:spPr>
-          <a:xfrm>
-            <a:off x="5486400" y="182880"/>
-            <a:ext cx="6217920" cy="548640"/>
-          </a:xfrm>
-          <a:prstGeom prst="rect">
-            <a:avLst/>
-          </a:prstGeom>
-          <a:noFill/>
-        </p:spPr>
-        <p:txBody>
-          <a:bodyPr wrap="square" anchor="ctr">
-            <a:spAutoFit/>
-          </a:bodyPr>
-          <a:lstStyle/>
-          <a:p>
             <a:pPr algn="ctr"/>
             <a:r>
               <a:rPr sz="1500" b="1">
@@ -14023,7 +13700,7 @@
         </p:nvSpPr>
         <p:spPr>
           <a:xfrm>
-            <a:off x="548640" y="2423160"/>
+            <a:off x="548640" y="3197860"/>
             <a:ext cx="11091672" cy="457200"/>
           </a:xfrm>
           <a:prstGeom prst="roundRect">
@@ -14069,7 +13746,7 @@
         </p:nvSpPr>
         <p:spPr>
           <a:xfrm>
-            <a:off x="777240" y="2423160"/>
+            <a:off x="777240" y="3197860"/>
             <a:ext cx="10634472" cy="457200"/>
           </a:xfrm>
           <a:prstGeom prst="rect">
@@ -14103,8 +13780,8 @@
         </p:nvSpPr>
         <p:spPr>
           <a:xfrm>
-            <a:off x="548640" y="2926080"/>
-            <a:ext cx="11091672" cy="3154680"/>
+            <a:off x="548640" y="3700780"/>
+            <a:ext cx="11091672" cy="1833880"/>
           </a:xfrm>
           <a:prstGeom prst="roundRect">
             <a:avLst>
@@ -14151,8 +13828,8 @@
         </p:nvSpPr>
         <p:spPr>
           <a:xfrm>
-            <a:off x="868680" y="3154680"/>
-            <a:ext cx="10424160" cy="2697480"/>
+            <a:off x="868680" y="3938524"/>
+            <a:ext cx="10424160" cy="1422400"/>
           </a:xfrm>
           <a:prstGeom prst="rect">
             <a:avLst/>
@@ -14391,16 +14068,40 @@
           </a:p>
         </p:txBody>
       </p:sp>
-      <p:sp>
-        <p:nvSpPr>
-          <p:cNvPr id="3" name="TextBox 2"/>
+      <p:pic>
+        <p:nvPicPr>
+          <p:cNvPr id="3" name="Picture 2" descr="starbem-logo-white.png"/>
+          <p:cNvPicPr>
+            <a:picLocks noChangeAspect="1"/>
+          </p:cNvPicPr>
+          <p:nvPr/>
+        </p:nvPicPr>
+        <p:blipFill>
+          <a:blip r:embed="rId2"/>
+          <a:stretch>
+            <a:fillRect/>
+          </a:stretch>
+        </p:blipFill>
+        <p:spPr>
+          <a:xfrm>
+            <a:off x="548640" y="265176"/>
+            <a:ext cx="1449238" cy="384048"/>
+          </a:xfrm>
+          <a:prstGeom prst="rect">
+            <a:avLst/>
+          </a:prstGeom>
+        </p:spPr>
+      </p:pic>
+      <p:sp>
+        <p:nvSpPr>
+          <p:cNvPr id="4" name="TextBox 3"/>
           <p:cNvSpPr txBox="1"/>
           <p:nvPr/>
         </p:nvSpPr>
         <p:spPr>
           <a:xfrm>
-            <a:off x="502920" y="182880"/>
-            <a:ext cx="4114800" cy="548640"/>
+            <a:off x="5486400" y="182880"/>
+            <a:ext cx="6217920" cy="548640"/>
           </a:xfrm>
           <a:prstGeom prst="rect">
             <a:avLst/>
@@ -14413,49 +14114,6 @@
           </a:bodyPr>
           <a:lstStyle/>
           <a:p>
-            <a:r>
-              <a:rPr sz="2200" b="1">
-                <a:solidFill>
-                  <a:srgbClr val="FFFFFF"/>
-                </a:solidFill>
-                <a:latin typeface="Calibri"/>
-              </a:rPr>
-              <a:t>★ </a:t>
-            </a:r>
-            <a:r>
-              <a:rPr sz="2000" b="1">
-                <a:solidFill>
-                  <a:srgbClr val="FFFFFF"/>
-                </a:solidFill>
-                <a:latin typeface="Funnel Display"/>
-              </a:rPr>
-              <a:t>starbem</a:t>
-            </a:r>
-          </a:p>
-        </p:txBody>
-      </p:sp>
-      <p:sp>
-        <p:nvSpPr>
-          <p:cNvPr id="4" name="TextBox 3"/>
-          <p:cNvSpPr txBox="1"/>
-          <p:nvPr/>
-        </p:nvSpPr>
-        <p:spPr>
-          <a:xfrm>
-            <a:off x="5486400" y="182880"/>
-            <a:ext cx="6217920" cy="548640"/>
-          </a:xfrm>
-          <a:prstGeom prst="rect">
-            <a:avLst/>
-          </a:prstGeom>
-          <a:noFill/>
-        </p:spPr>
-        <p:txBody>
-          <a:bodyPr wrap="square" anchor="ctr">
-            <a:spAutoFit/>
-          </a:bodyPr>
-          <a:lstStyle/>
-          <a:p>
             <a:pPr algn="ctr"/>
             <a:r>
               <a:rPr sz="1500" b="1">
@@ -14511,7 +14169,7 @@
         </p:nvSpPr>
         <p:spPr>
           <a:xfrm>
-            <a:off x="548640" y="2423160"/>
+            <a:off x="548640" y="2601214"/>
             <a:ext cx="5303520" cy="457200"/>
           </a:xfrm>
           <a:prstGeom prst="roundRect">
@@ -14557,7 +14215,7 @@
         </p:nvSpPr>
         <p:spPr>
           <a:xfrm>
-            <a:off x="777240" y="2423160"/>
+            <a:off x="777240" y="2601214"/>
             <a:ext cx="4846320" cy="457200"/>
           </a:xfrm>
           <a:prstGeom prst="rect">
@@ -14591,8 +14249,8 @@
         </p:nvSpPr>
         <p:spPr>
           <a:xfrm>
-            <a:off x="548640" y="2926080"/>
-            <a:ext cx="5303520" cy="3154680"/>
+            <a:off x="548640" y="3104134"/>
+            <a:ext cx="5303520" cy="3027171"/>
           </a:xfrm>
           <a:prstGeom prst="roundRect">
             <a:avLst>
@@ -14639,8 +14297,8 @@
         </p:nvSpPr>
         <p:spPr>
           <a:xfrm>
-            <a:off x="868680" y="3154680"/>
-            <a:ext cx="4663440" cy="2697480"/>
+            <a:off x="868680" y="3341878"/>
+            <a:ext cx="4663440" cy="2615691"/>
           </a:xfrm>
           <a:prstGeom prst="rect">
             <a:avLst/>
@@ -14894,7 +14552,7 @@
         </p:nvSpPr>
         <p:spPr>
           <a:xfrm>
-            <a:off x="6336792" y="2423160"/>
+            <a:off x="6336792" y="2601214"/>
             <a:ext cx="5303520" cy="457200"/>
           </a:xfrm>
           <a:prstGeom prst="roundRect">
@@ -14940,7 +14598,7 @@
         </p:nvSpPr>
         <p:spPr>
           <a:xfrm>
-            <a:off x="6565392" y="2423160"/>
+            <a:off x="6565392" y="2601214"/>
             <a:ext cx="4846320" cy="457200"/>
           </a:xfrm>
           <a:prstGeom prst="rect">
@@ -14974,8 +14632,8 @@
         </p:nvSpPr>
         <p:spPr>
           <a:xfrm>
-            <a:off x="6336792" y="2926080"/>
-            <a:ext cx="5303520" cy="3154680"/>
+            <a:off x="6336792" y="3104134"/>
+            <a:ext cx="5303520" cy="3027171"/>
           </a:xfrm>
           <a:prstGeom prst="roundRect">
             <a:avLst>
@@ -15022,8 +14680,8 @@
         </p:nvSpPr>
         <p:spPr>
           <a:xfrm>
-            <a:off x="6656831" y="3154680"/>
-            <a:ext cx="4663440" cy="2697480"/>
+            <a:off x="6656831" y="3341878"/>
+            <a:ext cx="4663440" cy="2615691"/>
           </a:xfrm>
           <a:prstGeom prst="rect">
             <a:avLst/>

</xml_diff>